<commit_message>
Phase G: rewrite docs for the full-LLM agentic + memory architecture
CLAUDE.md (overview + file map + invariants), README.md (setup/approach/memory tiers/worked example),
PROGRESS.md (status + changelog), deck/SLIDES.md + rebuilt deck.pptx. Old rules-engine descriptions replaced.

Co-Authored-By: Claude Opus 4.8 (1M context) <noreply@anthropic.com>
</commit_message>
<xml_diff>
--- a/docs/deck/deck.pptx
+++ b/docs/deck/deck.pptx
@@ -506,7 +506,7 @@
           <a:lstStyle/>
           <a:p>
             <a:r>
-              <a:t>We optimise for defensible, consistent triage under regulatory scrutiny — not raw model accuracy.</a:t>
+              <a:t>We optimise for a defensible, self-improving investigation — the model does the judging, a human closes the gap, memory makes it better.</a:t>
             </a:r>
           </a:p>
         </p:txBody>
@@ -576,7 +576,7 @@
           <a:lstStyle/>
           <a:p>
             <a:r>
-              <a:t>Single-process app, six modules — rules produce the number, the LLM only cross-checks it.</a:t>
+              <a:t>Parallel specialists for speed and focus; one agentic orchestrator with tools + full context for depth; memory makes each run smarter than the last.</a:t>
             </a:r>
           </a:p>
         </p:txBody>
@@ -646,7 +646,7 @@
           <a:lstStyle/>
           <a:p>
             <a:r>
-              <a:t>Determinism and auditability are engineered in — Decimal money, seeded data, no wall-clock in predicates.</a:t>
+              <a:t>The engineering is the harness around the model — tools, memory, the confidence gate, and the trace-as-audit — not a prompt.</a:t>
             </a:r>
           </a:p>
         </p:txBody>
@@ -716,7 +716,7 @@
           <a:lstStyle/>
           <a:p>
             <a:r>
-              <a:t>The interesting engineering is the guardrails — making a non-deterministic model safe inside a deterministic, auditable pipeline.</a:t>
+              <a:t>The interesting problem is making an autonomous investigator safe and auditable without a deterministic backstop.</a:t>
             </a:r>
           </a:p>
         </p:txBody>
@@ -786,7 +786,7 @@
           <a:lstStyle/>
           <a:p>
             <a:r>
-              <a:t>The POC proves the safe pipeline end-to-end; production is swapping fixtures for live feeds and closing the analyst feedback loop.</a:t>
+              <a:t>The POC proves the agentic loop + layered memory end-to-end; production is vector memory, live feeds, and tuned confidence.</a:t>
             </a:r>
           </a:p>
         </p:txBody>
@@ -3849,7 +3849,7 @@
               <a:defRPr sz="1500"/>
             </a:pPr>
             <a:r>
-              <a:t>- Compliance analysts triage fragmented signals (KYC, transactions, sanctions/PEP, adverse media)</a:t>
+              <a:t>- Compliance analysts triage fragmented signals (KYC, account, transactions, external alerts) under</a:t>
             </a:r>
           </a:p>
           <a:p>
@@ -3857,7 +3857,7 @@
               <a:defRPr sz="1500"/>
             </a:pPr>
             <a:r>
-              <a:t>- Objective: join per-customer signals into one dossier, score them **deterministically and</a:t>
+              <a:t>- Objective: join each customer's fragmented signals into one dossier, score and prioritise them,</a:t>
             </a:r>
           </a:p>
           <a:p>
@@ -3865,7 +3865,7 @@
               <a:defRPr sz="1500"/>
             </a:pPr>
             <a:r>
-              <a:t>- Design tension: a false negative (a missed sanctioned entity) is catastrophic; a false positive</a:t>
+              <a:t>- Design tension: a false negative is catastrophic, a false positive is expensive, and the reasoning</a:t>
             </a:r>
           </a:p>
           <a:p>
@@ -3873,7 +3873,7 @@
               <a:defRPr sz="1500"/>
             </a:pPr>
             <a:r>
-              <a:t>- North star: a *never-fails* engine — rules are the source of truth, the LLM is an advisory</a:t>
+              <a:t>- North star: a *fully-LLM, agentic* investigator that reads the whole dossier, is **honest about its</a:t>
             </a:r>
           </a:p>
         </p:txBody>
@@ -3904,7 +3904,7 @@
               <a:defRPr sz="1100" i="1"/>
             </a:pPr>
             <a:r>
-              <a:t>Note: We optimise for defensible, consistent triage under regulatory scrutiny — not raw model accuracy.</a:t>
+              <a:t>Note: We optimise for a defensible, self-improving investigation — the model does the judging, a human closes the gap, memory makes it better.</a:t>
             </a:r>
           </a:p>
         </p:txBody>
@@ -3984,7 +3984,7 @@
               <a:defRPr sz="1500"/>
             </a:pPr>
             <a:r>
-              <a:t>- Per-customer flow: dossier → rules score/band/findings → independent LLM score/confidence/</a:t>
+              <a:t>- Per-customer flow: retrieve memory → parallel specialists → agentic orchestrator → confidence-gate →</a:t>
             </a:r>
           </a:p>
           <a:p>
@@ -3992,7 +3992,7 @@
               <a:defRPr sz="1500"/>
             </a:pPr>
             <a:r>
-              <a:t>- Invariant: the rules score is the auditable number; the LLM never writes the arithmetic.</a:t>
+              <a:t>- 5-tier memory across 3 stores: working (Redis) · per-customer (relational) · episodic (case-bank) ·</a:t>
             </a:r>
           </a:p>
         </p:txBody>
@@ -4025,87 +4025,75 @@
               </a:defRPr>
             </a:pPr>
             <a:r>
-              <a:t>  data/generate.py ─► dossiers.json ─┐</a:t>
+              <a:t>  data/customers/CUST_xxx/  (structured + unstructured)</a:t>
             </a:r>
             <a:br/>
             <a:r>
-              <a:t>  (20 seeded synthetic profiles)     │</a:t>
+              <a:t>                 │</a:t>
             </a:r>
             <a:br/>
             <a:r>
-              <a:t>                                     ▼</a:t>
+              <a:t>                 ▼</a:t>
             </a:r>
             <a:br/>
             <a:r>
-              <a:t>  config.py ──────►  ┌─────────────────────────────────────────────┐</a:t>
+              <a:t>   memory.retrieve  ── per-customer history (relational) · similar cases (episodic)</a:t>
             </a:r>
             <a:br/>
             <a:r>
-              <a:t>  (the tuning knob)  │              engine.py (orchestrator)         │</a:t>
+              <a:t>                 │        · semantic cheat-sheets · lessons (procedural)</a:t>
             </a:r>
             <a:br/>
             <a:r>
-              <a:t>                     │                                               │</a:t>
+              <a:t>                 ▼</a:t>
             </a:r>
             <a:br/>
             <a:r>
-              <a:t>   rules.py  ───────►│  score_customer()   SOURCE OF TRUTH           │</a:t>
+              <a:t>   3 PARALLEL specialists  (KYC · transactions · documents)  memory-fed, one call each</a:t>
             </a:r>
             <a:br/>
             <a:r>
-              <a:t>   (deterministic)   │   overrides FIRST ─► weighted 0-100 ─► band   │</a:t>
+              <a:t>                 │  opinions</a:t>
             </a:r>
             <a:br/>
             <a:r>
-              <a:t>                     │          │                                    │</a:t>
+              <a:t>                 ▼</a:t>
             </a:r>
             <a:br/>
             <a:r>
-              <a:t>   llm.py  ─────────►│  crosscheck()  advisory, schema-locked        │</a:t>
+              <a:t>   AGENTIC ORCHESTRATOR  (serial tool-calling ReAct loop, temperature 0)</a:t>
             </a:r>
             <a:br/>
             <a:r>
-              <a:t>   (never-fails)     │   instructor+pydantic, temp 0, retry x3       │</a:t>
+              <a:t>     read_kyc · query/aggregate_transactions · find_txn_patterns (advisory)</a:t>
             </a:r>
             <a:br/>
             <a:r>
-              <a:t>                     │   └─ try/except ─► rules-only fallback        │</a:t>
+              <a:t>     · read_document · note/read_notes (Redis scratchpad) · finalize</a:t>
             </a:r>
             <a:br/>
             <a:r>
-              <a:t>                     │          │                                    │</a:t>
+              <a:t>                 │  RiskFinding (score/band/confidence/evidence)</a:t>
             </a:r>
             <a:br/>
             <a:r>
-              <a:t>                     │  reconcile(confidence) = 1-|rules-llm|/100    │</a:t>
+              <a:t>                 ▼</a:t>
             </a:r>
             <a:br/>
             <a:r>
-              <a:t>                     │  route()  kill-switch ─► band thresholds      │</a:t>
+              <a:t>   route_llm  ── confidence &lt; 0.60 ─► Redis review queue ─► Human panel ─► correction</a:t>
             </a:r>
             <a:br/>
             <a:r>
-              <a:t>                     └───────────────┬───────────────────────────────┘</a:t>
+              <a:t>                 │                                                  │ (human-verified episode + lessons)</a:t>
             </a:r>
             <a:br/>
             <a:r>
-              <a:t>                        drivers (sum │ to score)      ▼</a:t>
+              <a:t>                 ▼                                                  └─────────────► memory (write-back)</a:t>
             </a:r>
             <a:br/>
             <a:r>
-              <a:t>                        for explain  │        audit.py (append-only,</a:t>
-            </a:r>
-            <a:br/>
-            <a:r>
-              <a:t>                                     ▼        sha256 fingerprint)</a:t>
-            </a:r>
-            <a:br/>
-            <a:r>
-              <a:t>                            src/app/ (Streamlit)</a:t>
-            </a:r>
-            <a:br/>
-            <a:r>
-              <a:t>                        Queue ─► Case detail ─► Audit</a:t>
+              <a:t>   SQLite store (history) · append-only audit (the TOOL-CALL TRACE) · FastAPI + JS frontend</a:t>
             </a:r>
           </a:p>
         </p:txBody>
@@ -4136,7 +4124,7 @@
               <a:defRPr sz="1100" i="1"/>
             </a:pPr>
             <a:r>
-              <a:t>Note: Single-process app, six modules — rules produce the number, the LLM only cross-checks it.</a:t>
+              <a:t>Note: Parallel specialists for speed and focus; one agentic orchestrator with tools + full context for depth; memory makes each run smarter than the last.</a:t>
             </a:r>
           </a:p>
         </p:txBody>
@@ -4216,7 +4204,7 @@
               <a:defRPr sz="1500"/>
             </a:pPr>
             <a:r>
-              <a:t>- Rules as a registry of pure functions (~stdlib, no rules-engine DSL): overrides/vetoes</a:t>
+              <a:t>- Hybrid topology: three memory-fed specialists run in parallel (fast, focused), then a single</a:t>
             </a:r>
           </a:p>
           <a:p>
@@ -4224,7 +4212,7 @@
               <a:defRPr sz="1500"/>
             </a:pPr>
             <a:r>
-              <a:t>- Typology detectors are temporal, not amount-only — flagged on every customer *and* independently hunted by the LLM:</a:t>
+              <a:t>- Tools return facts, never verdicts. find_txn_patterns surfaces typology candidates with a</a:t>
             </a:r>
           </a:p>
           <a:p>
@@ -4232,7 +4220,7 @@
               <a:defRPr sz="1500"/>
             </a:pPr>
             <a:r>
-              <a:t>- LLM boundary = instructor + Pydantic v2: Field(ge=0,le=100), Literal band, field_validator</a:t>
+              <a:t>- Layered memory: a Redis scratchpad as working memory (evicted on every exit); a relational</a:t>
             </a:r>
           </a:p>
           <a:p>
@@ -4240,7 +4228,7 @@
               <a:defRPr sz="1500"/>
             </a:pPr>
             <a:r>
-              <a:t>- Never-fails guarantee: one try/except funnels every failure (no key, network, schema-invalid)</a:t>
+              <a:t>- Confidence-gated HITL + teach-the-model loop: low confidence → Redis review queue → the reviewer's</a:t>
             </a:r>
           </a:p>
           <a:p>
@@ -4248,7 +4236,7 @@
               <a:defRPr sz="1500"/>
             </a:pPr>
             <a:r>
-              <a:t>- Explainability = additive drivers that sum exactly to the score (hand-rolled SHAP local-accuracy,</a:t>
+              <a:t>- Auditability without arithmetic drivers: the ordered tool-call trace + evidence_refs +</a:t>
             </a:r>
           </a:p>
           <a:p>
@@ -4256,7 +4244,7 @@
               <a:defRPr sz="1500"/>
             </a:pPr>
             <a:r>
-              <a:t>- Audit: append-only AuditRecord per decision with sha256 input fingerprint + config snapshot.</a:t>
+              <a:t>- Reliability as loop hygiene: citation-check on evidence; a bounded loop / exception routes to a human</a:t>
             </a:r>
           </a:p>
         </p:txBody>
@@ -4287,7 +4275,7 @@
               <a:defRPr sz="1100" i="1"/>
             </a:pPr>
             <a:r>
-              <a:t>Note: Determinism and auditability are engineered in — Decimal money, seeded data, no wall-clock in predicates.</a:t>
+              <a:t>Note: The engineering is the harness around the model — tools, memory, the confidence gate, and the trace-as-audit — not a prompt.</a:t>
             </a:r>
           </a:p>
         </p:txBody>
@@ -4367,7 +4355,7 @@
               <a:defRPr sz="1500"/>
             </a:pPr>
             <a:r>
-              <a:t>- False-positive vs false-negative: we bias toward escalation — the rules-only and low-confidence</a:t>
+              <a:t>- Removing the deterministic safety net: the earlier design used rules as the source of truth. Going</a:t>
             </a:r>
           </a:p>
           <a:p>
@@ -4375,7 +4363,7 @@
               <a:defRPr sz="1500"/>
             </a:pPr>
             <a:r>
-              <a:t>- LLM non-determinism → deterministic guardrails: an LLM can hallucinate a score, so it is</a:t>
+              <a:t>- Echo-chamber risk: if the system learns from its own outputs, mistakes compound. We draw episodic</a:t>
             </a:r>
           </a:p>
           <a:p>
@@ -4383,7 +4371,7 @@
               <a:defRPr sz="1500"/>
             </a:pPr>
             <a:r>
-              <a:t>- Explainability is a hard requirement, not a nice-to-have: regulators inspect *closures* too, so</a:t>
+              <a:t>- Serial vs parallel: most models emit parallel tool calls; we force serial (parallel_tool_calls=False)</a:t>
             </a:r>
           </a:p>
           <a:p>
@@ -4391,7 +4379,7 @@
               <a:defRPr sz="1500"/>
             </a:pPr>
             <a:r>
-              <a:t>- Calibration is a first-class surface: all weights, floors, windows, bands, and routing</a:t>
+              <a:t>- Reproducibility: a fully-LLM score isn't byte-identical run-to-run. We set temperature=0 and **log</a:t>
             </a:r>
           </a:p>
           <a:p>
@@ -4399,7 +4387,7 @@
               <a:defRPr sz="1500"/>
             </a:pPr>
             <a:r>
-              <a:t>- Honest reflection: offline the "second opinion" is a *deterministic simulation*, clearly labelled</a:t>
+              <a:t>- Scoping to the brief: sanctions and adverse-media were deliberately cut — the brief names only</a:t>
             </a:r>
           </a:p>
         </p:txBody>
@@ -4430,7 +4418,7 @@
               <a:defRPr sz="1100" i="1"/>
             </a:pPr>
             <a:r>
-              <a:t>Note: The interesting engineering is the guardrails — making a non-deterministic model safe inside a deterministic, auditable pipeline.</a:t>
+              <a:t>Note: The interesting problem is making an autonomous investigator safe and auditable without a deterministic backstop.</a:t>
             </a:r>
           </a:p>
         </p:txBody>
@@ -4510,7 +4498,7 @@
               <a:defRPr sz="1500"/>
             </a:pPr>
             <a:r>
-              <a:t>- End-to-end demo: generate 20 dossiers → ranked triage Queue (risk bars) → Case detail</a:t>
+              <a:t>- End-to-end demo: the dashboard ranks 20 customers (gauges, confidence, pattern chips + charts); open a</a:t>
             </a:r>
           </a:p>
           <a:p>
@@ -4518,7 +4506,7 @@
               <a:defRPr sz="1500"/>
             </a:pPr>
             <a:r>
-              <a:t>- Worked contrast: CUST_018 (Iranian arms dealer, exact OFAC match + structuring) →</a:t>
+              <a:t>- Worked contrast: CUST_018 (Iranian arms dealer) → the agent runs read_kyc → query_transactions →</a:t>
             </a:r>
           </a:p>
           <a:p>
@@ -4534,7 +4522,7 @@
               <a:defRPr sz="1300"/>
             </a:pPr>
             <a:r>
-              <a:t>    - Real adverse-media / sanctions API feeds (World-Check, OFAC, Dow Jones) replacing fixtures.</a:t>
+              <a:t>    - Vector-embedding episodic recall (drop-in behind the case-bank's similar()), + per-customer change alerts.</a:t>
             </a:r>
           </a:p>
           <a:p>
@@ -4542,7 +4530,7 @@
               <a:defRPr sz="1300"/>
             </a:pPr>
             <a:r>
-              <a:t>    - ML-tuned thresholds — calibrate weights/cutoffs against labelled outcomes instead of hand-set values.</a:t>
+              <a:t>    - Re-add external-alert feeds (sanctions / adverse-media / World-Check) as tools the agent queries.</a:t>
             </a:r>
           </a:p>
           <a:p>
@@ -4550,7 +4538,7 @@
               <a:defRPr sz="1300"/>
             </a:pPr>
             <a:r>
-              <a:t>    - Case management — assignment, SLAs, disposition history, escalation workflow.</a:t>
+              <a:t>    - Confidence calibration against labelled outcomes; richer reviewer analytics.</a:t>
             </a:r>
           </a:p>
           <a:p>
@@ -4558,7 +4546,7 @@
               <a:defRPr sz="1300"/>
             </a:pPr>
             <a:r>
-              <a:t>    - Feedback loop — analyst decisions retrain scoring and recalibrate confidence over time.</a:t>
+              <a:t>    - Case management — assignment, SLAs, escalation workflow, and a fuller reflection cadence.</a:t>
             </a:r>
           </a:p>
         </p:txBody>
@@ -4589,7 +4577,7 @@
               <a:defRPr sz="1100" i="1"/>
             </a:pPr>
             <a:r>
-              <a:t>Note: The POC proves the safe pipeline end-to-end; production is swapping fixtures for live feeds and closing the analyst feedback loop.</a:t>
+              <a:t>Note: The POC proves the agentic loop + layered memory end-to-end; production is vector memory, live feeds, and tuned confidence.</a:t>
             </a:r>
           </a:p>
         </p:txBody>

</xml_diff>

<commit_message>
deck: drop the engineering-decisions box from slide 5
It was the densest block on an already-dense slide and duplicated points made
elsewhere in the deck. Moved to the slide's speaker notes so the content is
available if a reviewer asks, without competing with the KPI row and limits.

Co-Authored-By: Claude Opus 5 (1M context) <noreply@anthropic.com>
</commit_message>
<xml_diff>
--- a/docs/deck/deck.pptx
+++ b/docs/deck/deck.pptx
@@ -787,6 +787,12 @@
           <a:p>
             <a:r>
               <a:t>Close on the trade-offs, not the wins — showing you know where it is weak is more convincing than claiming it is finished. Each next step maps to a limit named above.</a:t>
+            </a:r>
+          </a:p>
+          <a:p/>
+          <a:p>
+            <a:r>
+              <a:t>If asked about engineering decisions: no deterministic scoring · sanctions deliberately scoped out (the brief said “external alerts”) · Decimal money · seeded byte-identical data generation · append-only audit of clears as well as escalations · working-memory scratchpad evicted on every exit path.</a:t>
             </a:r>
           </a:p>
         </p:txBody>
@@ -15619,138 +15625,6 @@
                 <a:latin typeface="Inter"/>
               </a:rPr>
               <a:t>assignment, SLAs, escalation workflow, reviewer analytics</a:t>
-            </a:r>
-          </a:p>
-        </p:txBody>
-      </p:sp>
-      <p:sp>
-        <p:nvSpPr>
-          <p:cNvPr id="54" name="Rounded Rectangle 53"/>
-          <p:cNvSpPr/>
-          <p:nvPr/>
-        </p:nvSpPr>
-        <p:spPr>
-          <a:xfrm>
-            <a:off x="548640" y="5705856"/>
-            <a:ext cx="11091672" cy="749808"/>
-          </a:xfrm>
-          <a:prstGeom prst="roundRect">
-            <a:avLst>
-              <a:gd name="adj" fmla="val 6000"/>
-            </a:avLst>
-          </a:prstGeom>
-          <a:solidFill>
-            <a:srgbClr val="1A1A1D"/>
-          </a:solidFill>
-          <a:ln w="9525">
-            <a:solidFill>
-              <a:srgbClr val="E4E4E7"/>
-            </a:solidFill>
-          </a:ln>
-          <a:effectLst/>
-        </p:spPr>
-        <p:style>
-          <a:lnRef idx="1">
-            <a:schemeClr val="accent1"/>
-          </a:lnRef>
-          <a:fillRef idx="3">
-            <a:schemeClr val="accent1"/>
-          </a:fillRef>
-          <a:effectRef idx="2">
-            <a:schemeClr val="accent1"/>
-          </a:effectRef>
-          <a:fontRef idx="minor">
-            <a:schemeClr val="lt1"/>
-          </a:fontRef>
-        </p:style>
-        <p:txBody>
-          <a:bodyPr rtlCol="0" anchor="ctr"/>
-          <a:lstStyle/>
-          <a:p>
-            <a:pPr algn="ctr"/>
-          </a:p>
-        </p:txBody>
-      </p:sp>
-      <p:sp>
-        <p:nvSpPr>
-          <p:cNvPr id="55" name="TextBox 54"/>
-          <p:cNvSpPr txBox="1"/>
-          <p:nvPr/>
-        </p:nvSpPr>
-        <p:spPr>
-          <a:xfrm>
-            <a:off x="749808" y="5797296"/>
-            <a:ext cx="10698480" cy="219456"/>
-          </a:xfrm>
-          <a:prstGeom prst="rect">
-            <a:avLst/>
-          </a:prstGeom>
-          <a:noFill/>
-        </p:spPr>
-        <p:txBody>
-          <a:bodyPr wrap="square" lIns="0" rIns="0" tIns="0" bIns="0">
-            <a:spAutoFit/>
-          </a:bodyPr>
-          <a:lstStyle/>
-          <a:p>
-            <a:pPr algn="l">
-              <a:lnSpc>
-                <a:spcPct val="125000"/>
-              </a:lnSpc>
-              <a:spcAft>
-                <a:spcPts val="600"/>
-              </a:spcAft>
-            </a:pPr>
-            <a:r>
-              <a:rPr sz="900" b="1">
-                <a:solidFill>
-                  <a:srgbClr val="71717A"/>
-                </a:solidFill>
-                <a:latin typeface="Inter"/>
-              </a:rPr>
-              <a:t>ENGINEERING DECISIONS WORTH DEFENDING</a:t>
-            </a:r>
-          </a:p>
-        </p:txBody>
-      </p:sp>
-      <p:sp>
-        <p:nvSpPr>
-          <p:cNvPr id="56" name="TextBox 55"/>
-          <p:cNvSpPr txBox="1"/>
-          <p:nvPr/>
-        </p:nvSpPr>
-        <p:spPr>
-          <a:xfrm>
-            <a:off x="749808" y="6016752"/>
-            <a:ext cx="10698480" cy="365760"/>
-          </a:xfrm>
-          <a:prstGeom prst="rect">
-            <a:avLst/>
-          </a:prstGeom>
-          <a:noFill/>
-        </p:spPr>
-        <p:txBody>
-          <a:bodyPr wrap="square" lIns="0" rIns="0" tIns="0" bIns="0">
-            <a:spAutoFit/>
-          </a:bodyPr>
-          <a:lstStyle/>
-          <a:p>
-            <a:pPr algn="l">
-              <a:lnSpc>
-                <a:spcPct val="120000"/>
-              </a:lnSpc>
-              <a:spcAft>
-                <a:spcPts val="600"/>
-              </a:spcAft>
-            </a:pPr>
-            <a:r>
-              <a:rPr sz="950" b="0">
-                <a:solidFill>
-                  <a:srgbClr val="A1A1AA"/>
-                </a:solidFill>
-                <a:latin typeface="Inter"/>
-              </a:rPr>
-              <a:t>No deterministic scoring · sanctions deliberately scoped out (the brief said “external alerts”) · Decimal money · seeded byte-identical data generation · append-only audit of clears as well as escalations · working-memory scratchpad evicted on every exit path</a:t>
             </a:r>
           </a:p>
         </p:txBody>

</xml_diff>

<commit_message>
deck: surface the real memory-tier names, restore "Human-in-the-Loop"
The plain-English pass stripped the actual terms of art, which cost credibility
with a technical audience. Both slides now carry the real name alongside the
plain one, in colour-matched mono so it reads as a label rather than clutter:

  Scratchpad    working memory        This person   per-customer history
  Past cases    episodic recall       The rulebook  semantic memory
  Lessons       procedural memory

Same treatment on slide 4's three learning paths (episodic / procedural /
per-customer), so the two slides use one consistent vocabulary.

Slide 4's kicker is back to "Human-in-the-Loop · Where People Come In" — the
industry term is what a reviewer scans for, and the plain gloss keeps it
readable for everyone else.

Co-Authored-By: Claude Opus 5 (1M context) <noreply@anthropic.com>
</commit_message>
<xml_diff>
--- a/docs/deck/deck.pptx
+++ b/docs/deck/deck.pptx
@@ -6664,7 +6664,7 @@
                 </a:solidFill>
                 <a:latin typeface="Inter"/>
               </a:rPr>
-              <a:t>Four steps per customer. There is no scoring formula anywhere in the code — the AI decides the number. The code just hands it the right tools, the right memory, and a set of rules it cannot break.</a:t>
+              <a:t>Four steps per customer. No scoring formula anywhere in the code — the AI decides the number; the code hands it the tools, the memory, and rules it cannot break.</a:t>
             </a:r>
           </a:p>
         </p:txBody>
@@ -8460,7 +8460,7 @@
         <p:spPr>
           <a:xfrm>
             <a:off x="6565392" y="3447288"/>
-            <a:ext cx="1371600" cy="219456"/>
+            <a:ext cx="1170432" cy="219456"/>
           </a:xfrm>
           <a:prstGeom prst="rect">
             <a:avLst/>
@@ -8501,8 +8501,8 @@
         </p:nvSpPr>
         <p:spPr>
           <a:xfrm>
-            <a:off x="8092440" y="3447288"/>
-            <a:ext cx="2377440" cy="219456"/>
+            <a:off x="7772400" y="3456432"/>
+            <a:ext cx="1481328" cy="219456"/>
           </a:xfrm>
           <a:prstGeom prst="rect">
             <a:avLst/>
@@ -8524,27 +8524,69 @@
               </a:spcAft>
             </a:pPr>
             <a:r>
+              <a:rPr sz="750" b="0">
+                <a:solidFill>
+                  <a:srgbClr val="F97316"/>
+                </a:solidFill>
+                <a:latin typeface="Consolas"/>
+              </a:rPr>
+              <a:t>working memory</a:t>
+            </a:r>
+          </a:p>
+        </p:txBody>
+      </p:sp>
+      <p:sp>
+        <p:nvSpPr>
+          <p:cNvPr id="43" name="TextBox 42"/>
+          <p:cNvSpPr txBox="1"/>
+          <p:nvPr/>
+        </p:nvSpPr>
+        <p:spPr>
+          <a:xfrm>
+            <a:off x="9308592" y="3447288"/>
+            <a:ext cx="1536192" cy="219456"/>
+          </a:xfrm>
+          <a:prstGeom prst="rect">
+            <a:avLst/>
+          </a:prstGeom>
+          <a:noFill/>
+        </p:spPr>
+        <p:txBody>
+          <a:bodyPr wrap="square" lIns="0" rIns="0" tIns="0" bIns="0">
+            <a:spAutoFit/>
+          </a:bodyPr>
+          <a:lstStyle/>
+          <a:p>
+            <a:pPr algn="l">
+              <a:lnSpc>
+                <a:spcPct val="125000"/>
+              </a:lnSpc>
+              <a:spcAft>
+                <a:spcPts val="600"/>
+              </a:spcAft>
+            </a:pPr>
+            <a:r>
               <a:rPr sz="850" b="0">
                 <a:solidFill>
                   <a:srgbClr val="A1A1AA"/>
                 </a:solidFill>
                 <a:latin typeface="Inter"/>
               </a:rPr>
-              <a:t>notes it takes while working</a:t>
-            </a:r>
-          </a:p>
-        </p:txBody>
-      </p:sp>
-      <p:sp>
-        <p:nvSpPr>
-          <p:cNvPr id="43" name="TextBox 42"/>
-          <p:cNvSpPr txBox="1"/>
-          <p:nvPr/>
-        </p:nvSpPr>
-        <p:spPr>
-          <a:xfrm>
-            <a:off x="10515600" y="3447288"/>
-            <a:ext cx="1097280" cy="219456"/>
+              <a:t>notes it takes as it goes</a:t>
+            </a:r>
+          </a:p>
+        </p:txBody>
+      </p:sp>
+      <p:sp>
+        <p:nvSpPr>
+          <p:cNvPr id="44" name="TextBox 43"/>
+          <p:cNvSpPr txBox="1"/>
+          <p:nvPr/>
+        </p:nvSpPr>
+        <p:spPr>
+          <a:xfrm>
+            <a:off x="10899648" y="3456432"/>
+            <a:ext cx="731520" cy="219456"/>
           </a:xfrm>
           <a:prstGeom prst="rect">
             <a:avLst/>
@@ -8566,7 +8608,7 @@
               </a:spcAft>
             </a:pPr>
             <a:r>
-              <a:rPr sz="800" b="0">
+              <a:rPr sz="750" b="0">
                 <a:solidFill>
                   <a:srgbClr val="71717A"/>
                 </a:solidFill>
@@ -8579,7 +8621,7 @@
       </p:sp>
       <p:sp>
         <p:nvSpPr>
-          <p:cNvPr id="44" name="Rounded Rectangle 43"/>
+          <p:cNvPr id="45" name="Rounded Rectangle 44"/>
           <p:cNvSpPr/>
           <p:nvPr/>
         </p:nvSpPr>
@@ -8625,7 +8667,7 @@
       </p:sp>
       <p:sp>
         <p:nvSpPr>
-          <p:cNvPr id="45" name="Rounded Rectangle 44"/>
+          <p:cNvPr id="46" name="Rounded Rectangle 45"/>
           <p:cNvSpPr/>
           <p:nvPr/>
         </p:nvSpPr>
@@ -8671,14 +8713,14 @@
       </p:sp>
       <p:sp>
         <p:nvSpPr>
-          <p:cNvPr id="46" name="TextBox 45"/>
+          <p:cNvPr id="47" name="TextBox 46"/>
           <p:cNvSpPr txBox="1"/>
           <p:nvPr/>
         </p:nvSpPr>
         <p:spPr>
           <a:xfrm>
             <a:off x="6565392" y="3785616"/>
-            <a:ext cx="1371600" cy="219456"/>
+            <a:ext cx="1170432" cy="219456"/>
           </a:xfrm>
           <a:prstGeom prst="rect">
             <a:avLst/>
@@ -8713,14 +8755,14 @@
       </p:sp>
       <p:sp>
         <p:nvSpPr>
-          <p:cNvPr id="47" name="TextBox 46"/>
-          <p:cNvSpPr txBox="1"/>
-          <p:nvPr/>
-        </p:nvSpPr>
-        <p:spPr>
-          <a:xfrm>
-            <a:off x="8092440" y="3785616"/>
-            <a:ext cx="2377440" cy="219456"/>
+          <p:cNvPr id="48" name="TextBox 47"/>
+          <p:cNvSpPr txBox="1"/>
+          <p:nvPr/>
+        </p:nvSpPr>
+        <p:spPr>
+          <a:xfrm>
+            <a:off x="7772400" y="3794760"/>
+            <a:ext cx="1481328" cy="219456"/>
           </a:xfrm>
           <a:prstGeom prst="rect">
             <a:avLst/>
@@ -8742,6 +8784,48 @@
               </a:spcAft>
             </a:pPr>
             <a:r>
+              <a:rPr sz="750" b="0">
+                <a:solidFill>
+                  <a:srgbClr val="71717A"/>
+                </a:solidFill>
+                <a:latin typeface="Consolas"/>
+              </a:rPr>
+              <a:t>per-customer history</a:t>
+            </a:r>
+          </a:p>
+        </p:txBody>
+      </p:sp>
+      <p:sp>
+        <p:nvSpPr>
+          <p:cNvPr id="49" name="TextBox 48"/>
+          <p:cNvSpPr txBox="1"/>
+          <p:nvPr/>
+        </p:nvSpPr>
+        <p:spPr>
+          <a:xfrm>
+            <a:off x="9308592" y="3785616"/>
+            <a:ext cx="1536192" cy="219456"/>
+          </a:xfrm>
+          <a:prstGeom prst="rect">
+            <a:avLst/>
+          </a:prstGeom>
+          <a:noFill/>
+        </p:spPr>
+        <p:txBody>
+          <a:bodyPr wrap="square" lIns="0" rIns="0" tIns="0" bIns="0">
+            <a:spAutoFit/>
+          </a:bodyPr>
+          <a:lstStyle/>
+          <a:p>
+            <a:pPr algn="l">
+              <a:lnSpc>
+                <a:spcPct val="125000"/>
+              </a:lnSpc>
+              <a:spcAft>
+                <a:spcPts val="600"/>
+              </a:spcAft>
+            </a:pPr>
+            <a:r>
               <a:rPr sz="850" b="0">
                 <a:solidFill>
                   <a:srgbClr val="A1A1AA"/>
@@ -8755,14 +8839,14 @@
       </p:sp>
       <p:sp>
         <p:nvSpPr>
-          <p:cNvPr id="48" name="TextBox 47"/>
-          <p:cNvSpPr txBox="1"/>
-          <p:nvPr/>
-        </p:nvSpPr>
-        <p:spPr>
-          <a:xfrm>
-            <a:off x="10515600" y="3785616"/>
-            <a:ext cx="1097280" cy="219456"/>
+          <p:cNvPr id="50" name="TextBox 49"/>
+          <p:cNvSpPr txBox="1"/>
+          <p:nvPr/>
+        </p:nvSpPr>
+        <p:spPr>
+          <a:xfrm>
+            <a:off x="10899648" y="3794760"/>
+            <a:ext cx="731520" cy="219456"/>
           </a:xfrm>
           <a:prstGeom prst="rect">
             <a:avLst/>
@@ -8784,20 +8868,20 @@
               </a:spcAft>
             </a:pPr>
             <a:r>
-              <a:rPr sz="800" b="0">
+              <a:rPr sz="750" b="0">
                 <a:solidFill>
                   <a:srgbClr val="71717A"/>
                 </a:solidFill>
                 <a:latin typeface="Inter"/>
               </a:rPr>
-              <a:t>kept forever</a:t>
-            </a:r>
-          </a:p>
-        </p:txBody>
-      </p:sp>
-      <p:sp>
-        <p:nvSpPr>
-          <p:cNvPr id="49" name="Rounded Rectangle 48"/>
+              <a:t>kept</a:t>
+            </a:r>
+          </a:p>
+        </p:txBody>
+      </p:sp>
+      <p:sp>
+        <p:nvSpPr>
+          <p:cNvPr id="51" name="Rounded Rectangle 50"/>
           <p:cNvSpPr/>
           <p:nvPr/>
         </p:nvSpPr>
@@ -8843,7 +8927,7 @@
       </p:sp>
       <p:sp>
         <p:nvSpPr>
-          <p:cNvPr id="50" name="Rounded Rectangle 49"/>
+          <p:cNvPr id="52" name="Rounded Rectangle 51"/>
           <p:cNvSpPr/>
           <p:nvPr/>
         </p:nvSpPr>
@@ -8889,14 +8973,14 @@
       </p:sp>
       <p:sp>
         <p:nvSpPr>
-          <p:cNvPr id="51" name="TextBox 50"/>
+          <p:cNvPr id="53" name="TextBox 52"/>
           <p:cNvSpPr txBox="1"/>
           <p:nvPr/>
         </p:nvSpPr>
         <p:spPr>
           <a:xfrm>
             <a:off x="6565392" y="4123944"/>
-            <a:ext cx="1371600" cy="219456"/>
+            <a:ext cx="1170432" cy="219456"/>
           </a:xfrm>
           <a:prstGeom prst="rect">
             <a:avLst/>
@@ -8931,14 +9015,14 @@
       </p:sp>
       <p:sp>
         <p:nvSpPr>
-          <p:cNvPr id="52" name="TextBox 51"/>
-          <p:cNvSpPr txBox="1"/>
-          <p:nvPr/>
-        </p:nvSpPr>
-        <p:spPr>
-          <a:xfrm>
-            <a:off x="8092440" y="4123944"/>
-            <a:ext cx="2377440" cy="219456"/>
+          <p:cNvPr id="54" name="TextBox 53"/>
+          <p:cNvSpPr txBox="1"/>
+          <p:nvPr/>
+        </p:nvSpPr>
+        <p:spPr>
+          <a:xfrm>
+            <a:off x="7772400" y="4133088"/>
+            <a:ext cx="1481328" cy="219456"/>
           </a:xfrm>
           <a:prstGeom prst="rect">
             <a:avLst/>
@@ -8960,6 +9044,48 @@
               </a:spcAft>
             </a:pPr>
             <a:r>
+              <a:rPr sz="750" b="0">
+                <a:solidFill>
+                  <a:srgbClr val="14B8A6"/>
+                </a:solidFill>
+                <a:latin typeface="Consolas"/>
+              </a:rPr>
+              <a:t>episodic recall</a:t>
+            </a:r>
+          </a:p>
+        </p:txBody>
+      </p:sp>
+      <p:sp>
+        <p:nvSpPr>
+          <p:cNvPr id="55" name="TextBox 54"/>
+          <p:cNvSpPr txBox="1"/>
+          <p:nvPr/>
+        </p:nvSpPr>
+        <p:spPr>
+          <a:xfrm>
+            <a:off x="9308592" y="4123944"/>
+            <a:ext cx="1536192" cy="219456"/>
+          </a:xfrm>
+          <a:prstGeom prst="rect">
+            <a:avLst/>
+          </a:prstGeom>
+          <a:noFill/>
+        </p:spPr>
+        <p:txBody>
+          <a:bodyPr wrap="square" lIns="0" rIns="0" tIns="0" bIns="0">
+            <a:spAutoFit/>
+          </a:bodyPr>
+          <a:lstStyle/>
+          <a:p>
+            <a:pPr algn="l">
+              <a:lnSpc>
+                <a:spcPct val="125000"/>
+              </a:lnSpc>
+              <a:spcAft>
+                <a:spcPts val="600"/>
+              </a:spcAft>
+            </a:pPr>
+            <a:r>
               <a:rPr sz="850" b="0">
                 <a:solidFill>
                   <a:srgbClr val="A1A1AA"/>
@@ -8973,14 +9099,14 @@
       </p:sp>
       <p:sp>
         <p:nvSpPr>
-          <p:cNvPr id="53" name="TextBox 52"/>
-          <p:cNvSpPr txBox="1"/>
-          <p:nvPr/>
-        </p:nvSpPr>
-        <p:spPr>
-          <a:xfrm>
-            <a:off x="10515600" y="4123944"/>
-            <a:ext cx="1097280" cy="219456"/>
+          <p:cNvPr id="56" name="TextBox 55"/>
+          <p:cNvSpPr txBox="1"/>
+          <p:nvPr/>
+        </p:nvSpPr>
+        <p:spPr>
+          <a:xfrm>
+            <a:off x="10899648" y="4133088"/>
+            <a:ext cx="731520" cy="219456"/>
           </a:xfrm>
           <a:prstGeom prst="rect">
             <a:avLst/>
@@ -9002,20 +9128,20 @@
               </a:spcAft>
             </a:pPr>
             <a:r>
-              <a:rPr sz="800" b="0">
+              <a:rPr sz="750" b="0">
                 <a:solidFill>
                   <a:srgbClr val="71717A"/>
                 </a:solidFill>
                 <a:latin typeface="Inter"/>
               </a:rPr>
-              <a:t>kept forever</a:t>
-            </a:r>
-          </a:p>
-        </p:txBody>
-      </p:sp>
-      <p:sp>
-        <p:nvSpPr>
-          <p:cNvPr id="54" name="Rounded Rectangle 53"/>
+              <a:t>kept</a:t>
+            </a:r>
+          </a:p>
+        </p:txBody>
+      </p:sp>
+      <p:sp>
+        <p:nvSpPr>
+          <p:cNvPr id="57" name="Rounded Rectangle 56"/>
           <p:cNvSpPr/>
           <p:nvPr/>
         </p:nvSpPr>
@@ -9061,7 +9187,7 @@
       </p:sp>
       <p:sp>
         <p:nvSpPr>
-          <p:cNvPr id="55" name="Rounded Rectangle 54"/>
+          <p:cNvPr id="58" name="Rounded Rectangle 57"/>
           <p:cNvSpPr/>
           <p:nvPr/>
         </p:nvSpPr>
@@ -9107,14 +9233,14 @@
       </p:sp>
       <p:sp>
         <p:nvSpPr>
-          <p:cNvPr id="56" name="TextBox 55"/>
+          <p:cNvPr id="59" name="TextBox 58"/>
           <p:cNvSpPr txBox="1"/>
           <p:nvPr/>
         </p:nvSpPr>
         <p:spPr>
           <a:xfrm>
             <a:off x="6565392" y="4462271"/>
-            <a:ext cx="1371600" cy="219456"/>
+            <a:ext cx="1170432" cy="219456"/>
           </a:xfrm>
           <a:prstGeom prst="rect">
             <a:avLst/>
@@ -9149,14 +9275,14 @@
       </p:sp>
       <p:sp>
         <p:nvSpPr>
-          <p:cNvPr id="57" name="TextBox 56"/>
-          <p:cNvSpPr txBox="1"/>
-          <p:nvPr/>
-        </p:nvSpPr>
-        <p:spPr>
-          <a:xfrm>
-            <a:off x="8092440" y="4462271"/>
-            <a:ext cx="2377440" cy="219456"/>
+          <p:cNvPr id="60" name="TextBox 59"/>
+          <p:cNvSpPr txBox="1"/>
+          <p:nvPr/>
+        </p:nvSpPr>
+        <p:spPr>
+          <a:xfrm>
+            <a:off x="7772400" y="4471415"/>
+            <a:ext cx="1481328" cy="219456"/>
           </a:xfrm>
           <a:prstGeom prst="rect">
             <a:avLst/>
@@ -9178,27 +9304,69 @@
               </a:spcAft>
             </a:pPr>
             <a:r>
+              <a:rPr sz="750" b="0">
+                <a:solidFill>
+                  <a:srgbClr val="0EA5E9"/>
+                </a:solidFill>
+                <a:latin typeface="Consolas"/>
+              </a:rPr>
+              <a:t>semantic memory</a:t>
+            </a:r>
+          </a:p>
+        </p:txBody>
+      </p:sp>
+      <p:sp>
+        <p:nvSpPr>
+          <p:cNvPr id="61" name="TextBox 60"/>
+          <p:cNvSpPr txBox="1"/>
+          <p:nvPr/>
+        </p:nvSpPr>
+        <p:spPr>
+          <a:xfrm>
+            <a:off x="9308592" y="4462271"/>
+            <a:ext cx="1536192" cy="219456"/>
+          </a:xfrm>
+          <a:prstGeom prst="rect">
+            <a:avLst/>
+          </a:prstGeom>
+          <a:noFill/>
+        </p:spPr>
+        <p:txBody>
+          <a:bodyPr wrap="square" lIns="0" rIns="0" tIns="0" bIns="0">
+            <a:spAutoFit/>
+          </a:bodyPr>
+          <a:lstStyle/>
+          <a:p>
+            <a:pPr algn="l">
+              <a:lnSpc>
+                <a:spcPct val="125000"/>
+              </a:lnSpc>
+              <a:spcAft>
+                <a:spcPts val="600"/>
+              </a:spcAft>
+            </a:pPr>
+            <a:r>
               <a:rPr sz="850" b="0">
                 <a:solidFill>
                   <a:srgbClr val="A1A1AA"/>
                 </a:solidFill>
                 <a:latin typeface="Inter"/>
               </a:rPr>
-              <a:t>what each crime pattern means</a:t>
-            </a:r>
-          </a:p>
-        </p:txBody>
-      </p:sp>
-      <p:sp>
-        <p:nvSpPr>
-          <p:cNvPr id="58" name="TextBox 57"/>
-          <p:cNvSpPr txBox="1"/>
-          <p:nvPr/>
-        </p:nvSpPr>
-        <p:spPr>
-          <a:xfrm>
-            <a:off x="10515600" y="4462271"/>
-            <a:ext cx="1097280" cy="219456"/>
+              <a:t>what each pattern means</a:t>
+            </a:r>
+          </a:p>
+        </p:txBody>
+      </p:sp>
+      <p:sp>
+        <p:nvSpPr>
+          <p:cNvPr id="62" name="TextBox 61"/>
+          <p:cNvSpPr txBox="1"/>
+          <p:nvPr/>
+        </p:nvSpPr>
+        <p:spPr>
+          <a:xfrm>
+            <a:off x="10899648" y="4471415"/>
+            <a:ext cx="731520" cy="219456"/>
           </a:xfrm>
           <a:prstGeom prst="rect">
             <a:avLst/>
@@ -9220,20 +9388,20 @@
               </a:spcAft>
             </a:pPr>
             <a:r>
-              <a:rPr sz="800" b="0">
+              <a:rPr sz="750" b="0">
                 <a:solidFill>
                   <a:srgbClr val="71717A"/>
                 </a:solidFill>
                 <a:latin typeface="Inter"/>
               </a:rPr>
-              <a:t>fixed reference</a:t>
-            </a:r>
-          </a:p>
-        </p:txBody>
-      </p:sp>
-      <p:sp>
-        <p:nvSpPr>
-          <p:cNvPr id="59" name="Rounded Rectangle 58"/>
+              <a:t>fixed</a:t>
+            </a:r>
+          </a:p>
+        </p:txBody>
+      </p:sp>
+      <p:sp>
+        <p:nvSpPr>
+          <p:cNvPr id="63" name="Rounded Rectangle 62"/>
           <p:cNvSpPr/>
           <p:nvPr/>
         </p:nvSpPr>
@@ -9279,7 +9447,7 @@
       </p:sp>
       <p:sp>
         <p:nvSpPr>
-          <p:cNvPr id="60" name="Rounded Rectangle 59"/>
+          <p:cNvPr id="64" name="Rounded Rectangle 63"/>
           <p:cNvSpPr/>
           <p:nvPr/>
         </p:nvSpPr>
@@ -9325,14 +9493,14 @@
       </p:sp>
       <p:sp>
         <p:nvSpPr>
-          <p:cNvPr id="61" name="TextBox 60"/>
+          <p:cNvPr id="65" name="TextBox 64"/>
           <p:cNvSpPr txBox="1"/>
           <p:nvPr/>
         </p:nvSpPr>
         <p:spPr>
           <a:xfrm>
             <a:off x="6565392" y="4800600"/>
-            <a:ext cx="1371600" cy="219456"/>
+            <a:ext cx="1170432" cy="219456"/>
           </a:xfrm>
           <a:prstGeom prst="rect">
             <a:avLst/>
@@ -9367,14 +9535,14 @@
       </p:sp>
       <p:sp>
         <p:nvSpPr>
-          <p:cNvPr id="62" name="TextBox 61"/>
-          <p:cNvSpPr txBox="1"/>
-          <p:nvPr/>
-        </p:nvSpPr>
-        <p:spPr>
-          <a:xfrm>
-            <a:off x="8092440" y="4800600"/>
-            <a:ext cx="2377440" cy="219456"/>
+          <p:cNvPr id="66" name="TextBox 65"/>
+          <p:cNvSpPr txBox="1"/>
+          <p:nvPr/>
+        </p:nvSpPr>
+        <p:spPr>
+          <a:xfrm>
+            <a:off x="7772400" y="4809744"/>
+            <a:ext cx="1481328" cy="219456"/>
           </a:xfrm>
           <a:prstGeom prst="rect">
             <a:avLst/>
@@ -9396,27 +9564,69 @@
               </a:spcAft>
             </a:pPr>
             <a:r>
+              <a:rPr sz="750" b="0">
+                <a:solidFill>
+                  <a:srgbClr val="8B5CF6"/>
+                </a:solidFill>
+                <a:latin typeface="Consolas"/>
+              </a:rPr>
+              <a:t>procedural memory</a:t>
+            </a:r>
+          </a:p>
+        </p:txBody>
+      </p:sp>
+      <p:sp>
+        <p:nvSpPr>
+          <p:cNvPr id="67" name="TextBox 66"/>
+          <p:cNvSpPr txBox="1"/>
+          <p:nvPr/>
+        </p:nvSpPr>
+        <p:spPr>
+          <a:xfrm>
+            <a:off x="9308592" y="4800600"/>
+            <a:ext cx="1536192" cy="219456"/>
+          </a:xfrm>
+          <a:prstGeom prst="rect">
+            <a:avLst/>
+          </a:prstGeom>
+          <a:noFill/>
+        </p:spPr>
+        <p:txBody>
+          <a:bodyPr wrap="square" lIns="0" rIns="0" tIns="0" bIns="0">
+            <a:spAutoFit/>
+          </a:bodyPr>
+          <a:lstStyle/>
+          <a:p>
+            <a:pPr algn="l">
+              <a:lnSpc>
+                <a:spcPct val="125000"/>
+              </a:lnSpc>
+              <a:spcAft>
+                <a:spcPts val="600"/>
+              </a:spcAft>
+            </a:pPr>
+            <a:r>
               <a:rPr sz="850" b="0">
                 <a:solidFill>
                   <a:srgbClr val="A1A1AA"/>
                 </a:solidFill>
                 <a:latin typeface="Inter"/>
               </a:rPr>
-              <a:t>where we got it wrong before</a:t>
-            </a:r>
-          </a:p>
-        </p:txBody>
-      </p:sp>
-      <p:sp>
-        <p:nvSpPr>
-          <p:cNvPr id="63" name="TextBox 62"/>
-          <p:cNvSpPr txBox="1"/>
-          <p:nvPr/>
-        </p:nvSpPr>
-        <p:spPr>
-          <a:xfrm>
-            <a:off x="10515600" y="4800600"/>
-            <a:ext cx="1097280" cy="219456"/>
+              <a:t>where we got it wrong</a:t>
+            </a:r>
+          </a:p>
+        </p:txBody>
+      </p:sp>
+      <p:sp>
+        <p:nvSpPr>
+          <p:cNvPr id="68" name="TextBox 67"/>
+          <p:cNvSpPr txBox="1"/>
+          <p:nvPr/>
+        </p:nvSpPr>
+        <p:spPr>
+          <a:xfrm>
+            <a:off x="10899648" y="4809744"/>
+            <a:ext cx="731520" cy="219456"/>
           </a:xfrm>
           <a:prstGeom prst="rect">
             <a:avLst/>
@@ -9438,20 +9648,20 @@
               </a:spcAft>
             </a:pPr>
             <a:r>
-              <a:rPr sz="800" b="0">
+              <a:rPr sz="750" b="0">
                 <a:solidFill>
                   <a:srgbClr val="71717A"/>
                 </a:solidFill>
                 <a:latin typeface="Inter"/>
               </a:rPr>
-              <a:t>grows as people fix</a:t>
-            </a:r>
-          </a:p>
-        </p:txBody>
-      </p:sp>
-      <p:sp>
-        <p:nvSpPr>
-          <p:cNvPr id="64" name="Rounded Rectangle 63"/>
+              <a:t>grows</a:t>
+            </a:r>
+          </a:p>
+        </p:txBody>
+      </p:sp>
+      <p:sp>
+        <p:nvSpPr>
+          <p:cNvPr id="69" name="Rounded Rectangle 68"/>
           <p:cNvSpPr/>
           <p:nvPr/>
         </p:nvSpPr>
@@ -9499,7 +9709,7 @@
       </p:sp>
       <p:sp>
         <p:nvSpPr>
-          <p:cNvPr id="65" name="TextBox 64"/>
+          <p:cNvPr id="70" name="TextBox 69"/>
           <p:cNvSpPr txBox="1"/>
           <p:nvPr/>
         </p:nvSpPr>
@@ -9541,7 +9751,7 @@
       </p:sp>
       <p:sp>
         <p:nvSpPr>
-          <p:cNvPr id="66" name="TextBox 65"/>
+          <p:cNvPr id="71" name="TextBox 70"/>
           <p:cNvSpPr txBox="1"/>
           <p:nvPr/>
         </p:nvSpPr>
@@ -9619,7 +9829,7 @@
       </p:sp>
       <p:sp>
         <p:nvSpPr>
-          <p:cNvPr id="67" name="Rounded Rectangle 66"/>
+          <p:cNvPr id="72" name="Rounded Rectangle 71"/>
           <p:cNvSpPr/>
           <p:nvPr/>
         </p:nvSpPr>
@@ -9667,7 +9877,7 @@
       </p:sp>
       <p:sp>
         <p:nvSpPr>
-          <p:cNvPr id="68" name="TextBox 67"/>
+          <p:cNvPr id="73" name="TextBox 72"/>
           <p:cNvSpPr txBox="1"/>
           <p:nvPr/>
         </p:nvSpPr>
@@ -9709,7 +9919,7 @@
       </p:sp>
       <p:sp>
         <p:nvSpPr>
-          <p:cNvPr id="69" name="TextBox 68"/>
+          <p:cNvPr id="74" name="TextBox 73"/>
           <p:cNvSpPr txBox="1"/>
           <p:nvPr/>
         </p:nvSpPr>
@@ -13104,7 +13314,7 @@
                 </a:solidFill>
                 <a:latin typeface="Inter"/>
               </a:rPr>
-              <a:t>04 · WHERE PEOPLE COME IN</a:t>
+              <a:t>04 · HUMAN-IN-THE-LOOP · WHERE PEOPLE COME IN</a:t>
             </a:r>
           </a:p>
         </p:txBody>
@@ -14230,7 +14440,7 @@
         <p:spPr>
           <a:xfrm>
             <a:off x="6446520" y="3209544"/>
-            <a:ext cx="5065776" cy="219456"/>
+            <a:ext cx="2377440" cy="219456"/>
           </a:xfrm>
           <a:prstGeom prst="rect">
             <a:avLst/>
@@ -14271,26 +14481,68 @@
         </p:nvSpPr>
         <p:spPr>
           <a:xfrm>
+            <a:off x="8887968" y="3218688"/>
+            <a:ext cx="1417320" cy="219456"/>
+          </a:xfrm>
+          <a:prstGeom prst="rect">
+            <a:avLst/>
+          </a:prstGeom>
+          <a:noFill/>
+        </p:spPr>
+        <p:txBody>
+          <a:bodyPr wrap="square" lIns="0" rIns="0" tIns="0" bIns="0">
+            <a:spAutoFit/>
+          </a:bodyPr>
+          <a:lstStyle/>
+          <a:p>
+            <a:pPr algn="l">
+              <a:lnSpc>
+                <a:spcPct val="125000"/>
+              </a:lnSpc>
+              <a:spcAft>
+                <a:spcPts val="600"/>
+              </a:spcAft>
+            </a:pPr>
+            <a:r>
+              <a:rPr sz="750" b="0">
+                <a:solidFill>
+                  <a:srgbClr val="14B8A6"/>
+                </a:solidFill>
+                <a:latin typeface="Consolas"/>
+              </a:rPr>
+              <a:t>episodic memory</a:t>
+            </a:r>
+          </a:p>
+        </p:txBody>
+      </p:sp>
+      <p:sp>
+        <p:nvSpPr>
+          <p:cNvPr id="29" name="TextBox 28"/>
+          <p:cNvSpPr txBox="1"/>
+          <p:nvPr/>
+        </p:nvSpPr>
+        <p:spPr>
+          <a:xfrm>
             <a:off x="6446520" y="3410712"/>
-            <a:ext cx="5084064" cy="164592"/>
-          </a:xfrm>
-          <a:prstGeom prst="rect">
-            <a:avLst/>
-          </a:prstGeom>
-          <a:noFill/>
-        </p:spPr>
-        <p:txBody>
-          <a:bodyPr wrap="square" lIns="0" rIns="0" tIns="0" bIns="0">
-            <a:spAutoFit/>
-          </a:bodyPr>
-          <a:lstStyle/>
-          <a:p>
-            <a:pPr algn="l">
-              <a:lnSpc>
-                <a:spcPct val="116000"/>
-              </a:lnSpc>
-              <a:spcAft>
-                <a:spcPts val="200"/>
+            <a:ext cx="5120640" cy="201168"/>
+          </a:xfrm>
+          <a:prstGeom prst="rect">
+            <a:avLst/>
+          </a:prstGeom>
+          <a:noFill/>
+        </p:spPr>
+        <p:txBody>
+          <a:bodyPr wrap="square" lIns="0" rIns="0" tIns="0" bIns="0">
+            <a:spAutoFit/>
+          </a:bodyPr>
+          <a:lstStyle/>
+          <a:p>
+            <a:pPr algn="l">
+              <a:lnSpc>
+                <a:spcPct val="125000"/>
+              </a:lnSpc>
+              <a:spcAft>
+                <a:spcPts val="600"/>
               </a:spcAft>
             </a:pPr>
             <a:r>
@@ -14307,7 +14559,7 @@
       </p:sp>
       <p:sp>
         <p:nvSpPr>
-          <p:cNvPr id="29" name="Rounded Rectangle 28"/>
+          <p:cNvPr id="30" name="Rounded Rectangle 29"/>
           <p:cNvSpPr/>
           <p:nvPr/>
         </p:nvSpPr>
@@ -14355,7 +14607,7 @@
       </p:sp>
       <p:sp>
         <p:nvSpPr>
-          <p:cNvPr id="30" name="Rectangle 29"/>
+          <p:cNvPr id="31" name="Rectangle 30"/>
           <p:cNvSpPr/>
           <p:nvPr/>
         </p:nvSpPr>
@@ -14399,14 +14651,14 @@
       </p:sp>
       <p:sp>
         <p:nvSpPr>
-          <p:cNvPr id="31" name="TextBox 30"/>
+          <p:cNvPr id="32" name="TextBox 31"/>
           <p:cNvSpPr txBox="1"/>
           <p:nvPr/>
         </p:nvSpPr>
         <p:spPr>
           <a:xfrm>
             <a:off x="6446520" y="3758184"/>
-            <a:ext cx="5065776" cy="219456"/>
+            <a:ext cx="2377440" cy="219456"/>
           </a:xfrm>
           <a:prstGeom prst="rect">
             <a:avLst/>
@@ -14441,32 +14693,74 @@
       </p:sp>
       <p:sp>
         <p:nvSpPr>
-          <p:cNvPr id="32" name="TextBox 31"/>
+          <p:cNvPr id="33" name="TextBox 32"/>
+          <p:cNvSpPr txBox="1"/>
+          <p:nvPr/>
+        </p:nvSpPr>
+        <p:spPr>
+          <a:xfrm>
+            <a:off x="8887968" y="3767328"/>
+            <a:ext cx="1417320" cy="219456"/>
+          </a:xfrm>
+          <a:prstGeom prst="rect">
+            <a:avLst/>
+          </a:prstGeom>
+          <a:noFill/>
+        </p:spPr>
+        <p:txBody>
+          <a:bodyPr wrap="square" lIns="0" rIns="0" tIns="0" bIns="0">
+            <a:spAutoFit/>
+          </a:bodyPr>
+          <a:lstStyle/>
+          <a:p>
+            <a:pPr algn="l">
+              <a:lnSpc>
+                <a:spcPct val="125000"/>
+              </a:lnSpc>
+              <a:spcAft>
+                <a:spcPts val="600"/>
+              </a:spcAft>
+            </a:pPr>
+            <a:r>
+              <a:rPr sz="750" b="0">
+                <a:solidFill>
+                  <a:srgbClr val="8B5CF6"/>
+                </a:solidFill>
+                <a:latin typeface="Consolas"/>
+              </a:rPr>
+              <a:t>procedural memory</a:t>
+            </a:r>
+          </a:p>
+        </p:txBody>
+      </p:sp>
+      <p:sp>
+        <p:nvSpPr>
+          <p:cNvPr id="34" name="TextBox 33"/>
           <p:cNvSpPr txBox="1"/>
           <p:nvPr/>
         </p:nvSpPr>
         <p:spPr>
           <a:xfrm>
             <a:off x="6446520" y="3959352"/>
-            <a:ext cx="5084064" cy="164592"/>
-          </a:xfrm>
-          <a:prstGeom prst="rect">
-            <a:avLst/>
-          </a:prstGeom>
-          <a:noFill/>
-        </p:spPr>
-        <p:txBody>
-          <a:bodyPr wrap="square" lIns="0" rIns="0" tIns="0" bIns="0">
-            <a:spAutoFit/>
-          </a:bodyPr>
-          <a:lstStyle/>
-          <a:p>
-            <a:pPr algn="l">
-              <a:lnSpc>
-                <a:spcPct val="116000"/>
-              </a:lnSpc>
-              <a:spcAft>
-                <a:spcPts val="200"/>
+            <a:ext cx="5120640" cy="201168"/>
+          </a:xfrm>
+          <a:prstGeom prst="rect">
+            <a:avLst/>
+          </a:prstGeom>
+          <a:noFill/>
+        </p:spPr>
+        <p:txBody>
+          <a:bodyPr wrap="square" lIns="0" rIns="0" tIns="0" bIns="0">
+            <a:spAutoFit/>
+          </a:bodyPr>
+          <a:lstStyle/>
+          <a:p>
+            <a:pPr algn="l">
+              <a:lnSpc>
+                <a:spcPct val="125000"/>
+              </a:lnSpc>
+              <a:spcAft>
+                <a:spcPts val="600"/>
               </a:spcAft>
             </a:pPr>
             <a:r>
@@ -14483,7 +14777,7 @@
       </p:sp>
       <p:sp>
         <p:nvSpPr>
-          <p:cNvPr id="33" name="Rounded Rectangle 32"/>
+          <p:cNvPr id="35" name="Rounded Rectangle 34"/>
           <p:cNvSpPr/>
           <p:nvPr/>
         </p:nvSpPr>
@@ -14531,7 +14825,7 @@
       </p:sp>
       <p:sp>
         <p:nvSpPr>
-          <p:cNvPr id="34" name="Rectangle 33"/>
+          <p:cNvPr id="36" name="Rectangle 35"/>
           <p:cNvSpPr/>
           <p:nvPr/>
         </p:nvSpPr>
@@ -14575,14 +14869,14 @@
       </p:sp>
       <p:sp>
         <p:nvSpPr>
-          <p:cNvPr id="35" name="TextBox 34"/>
+          <p:cNvPr id="37" name="TextBox 36"/>
           <p:cNvSpPr txBox="1"/>
           <p:nvPr/>
         </p:nvSpPr>
         <p:spPr>
           <a:xfrm>
             <a:off x="6446520" y="4306824"/>
-            <a:ext cx="5065776" cy="219456"/>
+            <a:ext cx="2377440" cy="219456"/>
           </a:xfrm>
           <a:prstGeom prst="rect">
             <a:avLst/>
@@ -14617,32 +14911,74 @@
       </p:sp>
       <p:sp>
         <p:nvSpPr>
-          <p:cNvPr id="36" name="TextBox 35"/>
+          <p:cNvPr id="38" name="TextBox 37"/>
+          <p:cNvSpPr txBox="1"/>
+          <p:nvPr/>
+        </p:nvSpPr>
+        <p:spPr>
+          <a:xfrm>
+            <a:off x="8887968" y="4315968"/>
+            <a:ext cx="1417320" cy="219456"/>
+          </a:xfrm>
+          <a:prstGeom prst="rect">
+            <a:avLst/>
+          </a:prstGeom>
+          <a:noFill/>
+        </p:spPr>
+        <p:txBody>
+          <a:bodyPr wrap="square" lIns="0" rIns="0" tIns="0" bIns="0">
+            <a:spAutoFit/>
+          </a:bodyPr>
+          <a:lstStyle/>
+          <a:p>
+            <a:pPr algn="l">
+              <a:lnSpc>
+                <a:spcPct val="125000"/>
+              </a:lnSpc>
+              <a:spcAft>
+                <a:spcPts val="600"/>
+              </a:spcAft>
+            </a:pPr>
+            <a:r>
+              <a:rPr sz="750" b="0">
+                <a:solidFill>
+                  <a:srgbClr val="0EA5E9"/>
+                </a:solidFill>
+                <a:latin typeface="Consolas"/>
+              </a:rPr>
+              <a:t>per-customer history</a:t>
+            </a:r>
+          </a:p>
+        </p:txBody>
+      </p:sp>
+      <p:sp>
+        <p:nvSpPr>
+          <p:cNvPr id="39" name="TextBox 38"/>
           <p:cNvSpPr txBox="1"/>
           <p:nvPr/>
         </p:nvSpPr>
         <p:spPr>
           <a:xfrm>
             <a:off x="6446520" y="4507992"/>
-            <a:ext cx="5084064" cy="164592"/>
-          </a:xfrm>
-          <a:prstGeom prst="rect">
-            <a:avLst/>
-          </a:prstGeom>
-          <a:noFill/>
-        </p:spPr>
-        <p:txBody>
-          <a:bodyPr wrap="square" lIns="0" rIns="0" tIns="0" bIns="0">
-            <a:spAutoFit/>
-          </a:bodyPr>
-          <a:lstStyle/>
-          <a:p>
-            <a:pPr algn="l">
-              <a:lnSpc>
-                <a:spcPct val="116000"/>
-              </a:lnSpc>
-              <a:spcAft>
-                <a:spcPts val="200"/>
+            <a:ext cx="5120640" cy="201168"/>
+          </a:xfrm>
+          <a:prstGeom prst="rect">
+            <a:avLst/>
+          </a:prstGeom>
+          <a:noFill/>
+        </p:spPr>
+        <p:txBody>
+          <a:bodyPr wrap="square" lIns="0" rIns="0" tIns="0" bIns="0">
+            <a:spAutoFit/>
+          </a:bodyPr>
+          <a:lstStyle/>
+          <a:p>
+            <a:pPr algn="l">
+              <a:lnSpc>
+                <a:spcPct val="125000"/>
+              </a:lnSpc>
+              <a:spcAft>
+                <a:spcPts val="600"/>
               </a:spcAft>
             </a:pPr>
             <a:r>
@@ -14659,7 +14995,7 @@
       </p:sp>
       <p:sp>
         <p:nvSpPr>
-          <p:cNvPr id="37" name="TextBox 36"/>
+          <p:cNvPr id="40" name="TextBox 39"/>
           <p:cNvSpPr txBox="1"/>
           <p:nvPr/>
         </p:nvSpPr>
@@ -14719,7 +15055,7 @@
       </p:sp>
       <p:sp>
         <p:nvSpPr>
-          <p:cNvPr id="38" name="Rounded Rectangle 37"/>
+          <p:cNvPr id="41" name="Rounded Rectangle 40"/>
           <p:cNvSpPr/>
           <p:nvPr/>
         </p:nvSpPr>
@@ -14767,7 +15103,7 @@
       </p:sp>
       <p:sp>
         <p:nvSpPr>
-          <p:cNvPr id="39" name="TextBox 38"/>
+          <p:cNvPr id="42" name="TextBox 41"/>
           <p:cNvSpPr txBox="1"/>
           <p:nvPr/>
         </p:nvSpPr>
@@ -14809,7 +15145,7 @@
       </p:sp>
       <p:sp>
         <p:nvSpPr>
-          <p:cNvPr id="40" name="TextBox 39"/>
+          <p:cNvPr id="43" name="TextBox 42"/>
           <p:cNvSpPr txBox="1"/>
           <p:nvPr/>
         </p:nvSpPr>

</xml_diff>